<commit_message>
a lot of reviewing for the test
</commit_message>
<xml_diff>
--- a/Part 1 Lectures/6_CNN_Intro.pptx
+++ b/Part 1 Lectures/6_CNN_Intro.pptx
@@ -169,15 +169,38 @@
 </p:presentation>
 </file>
 
+<file path=ppt/revisionInfo.xml><?xml version="1.0" encoding="utf-8"?>
+<p1510:revInfo xmlns:a="http://schemas.openxmlformats.org/drawingml/2006/main" xmlns:r="http://schemas.openxmlformats.org/officeDocument/2006/relationships" xmlns:p1510="http://schemas.microsoft.com/office/powerpoint/2015/10/main">
+  <p1510:revLst>
+    <p1510:client id="{FD1A1A19-F963-437F-A43B-F9F18B08D8E9}" v="1" dt="2025-09-28T18:43:03.410"/>
+  </p1510:revLst>
+</p1510:revInfo>
+</file>
+
 <file path=ppt/changesInfos/changesInfo1.xml><?xml version="1.0" encoding="utf-8"?>
 <pc:chgInfo xmlns:a="http://schemas.openxmlformats.org/drawingml/2006/main" xmlns:r="http://schemas.openxmlformats.org/officeDocument/2006/relationships" xmlns:ac="http://schemas.microsoft.com/office/drawing/2013/main/command" xmlns:pc="http://schemas.microsoft.com/office/powerpoint/2013/main/command">
   <pc:docChgLst>
     <pc:chgData name="Israel Trejo" userId="94abe8331a44785d" providerId="LiveId" clId="{C64EC362-DB82-4CB5-B399-A3CE20D8262C}"/>
-    <pc:docChg chg="delSld">
-      <pc:chgData name="Israel Trejo" userId="94abe8331a44785d" providerId="LiveId" clId="{C64EC362-DB82-4CB5-B399-A3CE20D8262C}" dt="2025-09-20T21:00:45.523" v="0" actId="2696"/>
+    <pc:docChg chg="delSld modSld">
+      <pc:chgData name="Israel Trejo" userId="94abe8331a44785d" providerId="LiveId" clId="{C64EC362-DB82-4CB5-B399-A3CE20D8262C}" dt="2025-09-28T18:43:03.405" v="1" actId="1076"/>
       <pc:docMkLst>
         <pc:docMk/>
       </pc:docMkLst>
+      <pc:sldChg chg="modSp">
+        <pc:chgData name="Israel Trejo" userId="94abe8331a44785d" providerId="LiveId" clId="{C64EC362-DB82-4CB5-B399-A3CE20D8262C}" dt="2025-09-28T18:43:03.405" v="1" actId="1076"/>
+        <pc:sldMkLst>
+          <pc:docMk/>
+          <pc:sldMk cId="0" sldId="435"/>
+        </pc:sldMkLst>
+        <pc:picChg chg="mod">
+          <ac:chgData name="Israel Trejo" userId="94abe8331a44785d" providerId="LiveId" clId="{C64EC362-DB82-4CB5-B399-A3CE20D8262C}" dt="2025-09-28T18:43:03.405" v="1" actId="1076"/>
+          <ac:picMkLst>
+            <pc:docMk/>
+            <pc:sldMk cId="0" sldId="435"/>
+            <ac:picMk id="23560" creationId="{AAEFC6CF-CDAA-3344-4CA7-A14FAE8F0DAB}"/>
+          </ac:picMkLst>
+        </pc:picChg>
+      </pc:sldChg>
       <pc:sldChg chg="del">
         <pc:chgData name="Israel Trejo" userId="94abe8331a44785d" providerId="LiveId" clId="{C64EC362-DB82-4CB5-B399-A3CE20D8262C}" dt="2025-09-20T21:00:45.523" v="0" actId="2696"/>
         <pc:sldMkLst>
@@ -272,7 +295,7 @@
           <a:p>
             <a:fld id="{FC78DA6D-BA35-47CD-BB0B-F04D34A1F301}" type="datetimeFigureOut">
               <a:rPr lang="en-US" smtClean="0"/>
-              <a:t>9/20/2025</a:t>
+              <a:t>9/28/2025</a:t>
             </a:fld>
             <a:endParaRPr lang="en-US"/>
           </a:p>
@@ -2204,7 +2227,7 @@
                 </a:solidFill>
               </a:rPr>
               <a:pPr defTabSz="756117"/>
-              <a:t>9/20/2025</a:t>
+              <a:t>9/28/2025</a:t>
             </a:fld>
             <a:endParaRPr lang="en-US" sz="1488">
               <a:solidFill>
@@ -4516,7 +4539,7 @@
               <a:buNone/>
             </a:pPr>
             <a:r>
-              <a:rPr lang="en-US" altLang="en-US" sz="1488" b="1">
+              <a:rPr lang="en-US" altLang="en-US" sz="1488" b="1" dirty="0">
                 <a:solidFill>
                   <a:srgbClr val="292929"/>
                 </a:solidFill>
@@ -4525,7 +4548,7 @@
               <a:t>n</a:t>
             </a:r>
             <a:r>
-              <a:rPr lang="en-US" altLang="en-US" sz="1488">
+              <a:rPr lang="en-US" altLang="en-US" sz="1488" dirty="0">
                 <a:solidFill>
                   <a:srgbClr val="292929"/>
                 </a:solidFill>
@@ -4544,7 +4567,7 @@
               <a:buNone/>
             </a:pPr>
             <a:r>
-              <a:rPr lang="en-US" altLang="en-US" sz="1488" b="1">
+              <a:rPr lang="en-US" altLang="en-US" sz="1488" b="1" dirty="0">
                 <a:solidFill>
                   <a:srgbClr val="292929"/>
                 </a:solidFill>
@@ -4553,7 +4576,7 @@
               <a:t>p</a:t>
             </a:r>
             <a:r>
-              <a:rPr lang="en-US" altLang="en-US" sz="1488">
+              <a:rPr lang="en-US" altLang="en-US" sz="1488" dirty="0">
                 <a:solidFill>
                   <a:srgbClr val="292929"/>
                 </a:solidFill>
@@ -4561,7 +4584,7 @@
               </a:rPr>
               <a:t> the size of the filter. For example, for an initial 120x120px image and with a 5x5 kernel, the featured is sized 116x116px, </a:t>
             </a:r>
-            <a:endParaRPr lang="en-US" altLang="en-US" sz="1488"/>
+            <a:endParaRPr lang="en-US" altLang="en-US" sz="1488" dirty="0"/>
           </a:p>
         </p:txBody>
       </p:sp>
@@ -4800,7 +4823,7 @@
               <a:buNone/>
             </a:pPr>
             <a:r>
-              <a:rPr lang="en-US" altLang="en-US" sz="1488">
+              <a:rPr lang="en-US" altLang="en-US" sz="1488" dirty="0">
                 <a:solidFill>
                   <a:srgbClr val="292929"/>
                 </a:solidFill>
@@ -4808,7 +4831,7 @@
               </a:rPr>
               <a:t>What If we want to output a feature map with the same size as the input image</a:t>
             </a:r>
-            <a:endParaRPr lang="en-US" altLang="en-US" sz="1488"/>
+            <a:endParaRPr lang="en-US" altLang="en-US" sz="1488" dirty="0"/>
           </a:p>
         </p:txBody>
       </p:sp>
@@ -5047,7 +5070,7 @@
               <a:buNone/>
             </a:pPr>
             <a:r>
-              <a:rPr lang="en-US" altLang="en-US" sz="1488">
+              <a:rPr lang="en-US" altLang="en-US" sz="1488" dirty="0">
                 <a:solidFill>
                   <a:srgbClr val="292929"/>
                 </a:solidFill>
@@ -5056,7 +5079,7 @@
               <a:t>Padding </a:t>
             </a:r>
             <a:r>
-              <a:rPr lang="en-US" altLang="en-US" sz="1488">
+              <a:rPr lang="en-US" altLang="en-US" sz="1488" dirty="0">
                 <a:solidFill>
                   <a:srgbClr val="292929"/>
                 </a:solidFill>
@@ -5066,7 +5089,7 @@
               <a:t> </a:t>
             </a:r>
             <a:r>
-              <a:rPr lang="en-US" altLang="en-US" sz="1488">
+              <a:rPr lang="en-US" altLang="en-US" sz="1488" dirty="0">
                 <a:solidFill>
                   <a:srgbClr val="292929"/>
                 </a:solidFill>
@@ -5074,7 +5097,7 @@
               </a:rPr>
               <a:t>add zeros around the input image before the convolution, the input image is “padded with zeros”</a:t>
             </a:r>
-            <a:endParaRPr lang="en-US" altLang="en-US" sz="1488"/>
+            <a:endParaRPr lang="en-US" altLang="en-US" sz="1488" dirty="0"/>
           </a:p>
         </p:txBody>
       </p:sp>
@@ -5313,7 +5336,7 @@
               <a:buNone/>
             </a:pPr>
             <a:r>
-              <a:rPr lang="en-US" altLang="en-US" sz="1488">
+              <a:rPr lang="en-US" altLang="en-US" sz="1488" dirty="0">
                 <a:solidFill>
                   <a:srgbClr val="292929"/>
                 </a:solidFill>
@@ -5321,7 +5344,7 @@
               </a:rPr>
               <a:t>6x6px with a 3x3 convolution filter. In the equation given above we then have p = 3, m = 6 so it comes that n = 6 + 3–1 = 8. Thus, it is necessary to have an input image sized 8x8px, which means we must add zeros all around the original matrix image to reach a size of 8x8px</a:t>
             </a:r>
-            <a:endParaRPr lang="en-US" altLang="en-US" sz="1488"/>
+            <a:endParaRPr lang="en-US" altLang="en-US" sz="1488" dirty="0"/>
           </a:p>
         </p:txBody>
       </p:sp>
@@ -5354,7 +5377,7 @@
         </p:blipFill>
         <p:spPr bwMode="auto">
           <a:xfrm>
-            <a:off x="6401782" y="3335387"/>
+            <a:off x="6542889" y="3394454"/>
             <a:ext cx="2055574" cy="2276096"/>
           </a:xfrm>
           <a:prstGeom prst="rect">

</xml_diff>